<commit_message>
fix: remove TCS header/kicker, blue cut, nav, QR dup, pipeline highlight, badges, hero umbrella tabs, PPT shape repair
</commit_message>
<xml_diff>
--- a/slides/rag_explainer.pptx
+++ b/slides/rag_explainer.pptx
@@ -111,7 +111,7 @@
       <p:sp>
         <p:nvSpPr>
           <p:cNvPr id="2" name="Title"/>
-          <p:cNvPr/>
+          <p:cNvSpPr/>
           <p:nvPr/>
         </p:nvSpPr>
         <p:spPr>
@@ -122,9 +122,7 @@
           <a:prstGeom prst="rect">
             <a:avLst/>
           </a:prstGeom>
-          <a:solidFill>
-            <a:noFill/>
-          </a:solidFill>
+          <a:noFill/>
           <a:ln>
             <a:noFill/>
           </a:ln>
@@ -174,7 +172,7 @@
       <p:sp>
         <p:nvSpPr>
           <p:cNvPr id="5" name="Footer"/>
-          <p:cNvPr/>
+          <p:cNvSpPr/>
           <p:nvPr/>
         </p:nvSpPr>
         <p:spPr>
@@ -185,9 +183,7 @@
           <a:prstGeom prst="rect">
             <a:avLst/>
           </a:prstGeom>
-          <a:solidFill>
-            <a:noFill/>
-          </a:solidFill>
+          <a:noFill/>
           <a:ln>
             <a:noFill/>
           </a:ln>
@@ -238,7 +234,7 @@
       <p:sp>
         <p:nvSpPr>
           <p:cNvPr id="2" name="Header"/>
-          <p:cNvPr/>
+          <p:cNvSpPr/>
           <p:nvPr/>
         </p:nvSpPr>
         <p:spPr>
@@ -249,9 +245,7 @@
           <a:prstGeom prst="rect">
             <a:avLst/>
           </a:prstGeom>
-          <a:solidFill>
-            <a:noFill/>
-          </a:solidFill>
+          <a:noFill/>
           <a:ln>
             <a:noFill/>
           </a:ln>
@@ -300,7 +294,7 @@
       <p:sp>
         <p:nvSpPr>
           <p:cNvPr id="3" name="Body"/>
-          <p:cNvPr/>
+          <p:cNvSpPr/>
           <p:nvPr/>
         </p:nvSpPr>
         <p:spPr>
@@ -311,9 +305,7 @@
           <a:prstGeom prst="rect">
             <a:avLst/>
           </a:prstGeom>
-          <a:solidFill>
-            <a:noFill/>
-          </a:solidFill>
+          <a:noFill/>
           <a:ln>
             <a:noFill/>
           </a:ln>
@@ -411,7 +403,7 @@
       <p:sp>
         <p:nvSpPr>
           <p:cNvPr id="4" name="Side"/>
-          <p:cNvPr/>
+          <p:cNvSpPr/>
           <p:nvPr/>
         </p:nvSpPr>
         <p:spPr>
@@ -422,9 +414,7 @@
           <a:prstGeom prst="rect">
             <a:avLst/>
           </a:prstGeom>
-          <a:solidFill>
-            <a:noFill/>
-          </a:solidFill>
+          <a:noFill/>
           <a:ln>
             <a:noFill/>
           </a:ln>
@@ -525,7 +515,7 @@
       <p:sp>
         <p:nvSpPr>
           <p:cNvPr id="5" name="Footer"/>
-          <p:cNvPr/>
+          <p:cNvSpPr/>
           <p:nvPr/>
         </p:nvSpPr>
         <p:spPr>
@@ -536,9 +526,7 @@
           <a:prstGeom prst="rect">
             <a:avLst/>
           </a:prstGeom>
-          <a:solidFill>
-            <a:noFill/>
-          </a:solidFill>
+          <a:noFill/>
           <a:ln>
             <a:noFill/>
           </a:ln>
@@ -589,7 +577,7 @@
       <p:sp>
         <p:nvSpPr>
           <p:cNvPr id="2" name="Header"/>
-          <p:cNvPr/>
+          <p:cNvSpPr/>
           <p:nvPr/>
         </p:nvSpPr>
         <p:spPr>
@@ -600,9 +588,7 @@
           <a:prstGeom prst="rect">
             <a:avLst/>
           </a:prstGeom>
-          <a:solidFill>
-            <a:noFill/>
-          </a:solidFill>
+          <a:noFill/>
           <a:ln>
             <a:noFill/>
           </a:ln>
@@ -651,7 +637,7 @@
       <p:sp>
         <p:nvSpPr>
           <p:cNvPr id="3" name="Body"/>
-          <p:cNvPr/>
+          <p:cNvSpPr/>
           <p:nvPr/>
         </p:nvSpPr>
         <p:spPr>
@@ -662,9 +648,7 @@
           <a:prstGeom prst="rect">
             <a:avLst/>
           </a:prstGeom>
-          <a:solidFill>
-            <a:noFill/>
-          </a:solidFill>
+          <a:noFill/>
           <a:ln>
             <a:noFill/>
           </a:ln>
@@ -739,7 +723,7 @@
       <p:sp>
         <p:nvSpPr>
           <p:cNvPr id="4" name="Side"/>
-          <p:cNvPr/>
+          <p:cNvSpPr/>
           <p:nvPr/>
         </p:nvSpPr>
         <p:spPr>
@@ -750,9 +734,7 @@
           <a:prstGeom prst="rect">
             <a:avLst/>
           </a:prstGeom>
-          <a:solidFill>
-            <a:noFill/>
-          </a:solidFill>
+          <a:noFill/>
           <a:ln>
             <a:noFill/>
           </a:ln>
@@ -816,7 +798,7 @@
       <p:sp>
         <p:nvSpPr>
           <p:cNvPr id="5" name="Footer"/>
-          <p:cNvPr/>
+          <p:cNvSpPr/>
           <p:nvPr/>
         </p:nvSpPr>
         <p:spPr>
@@ -827,9 +809,7 @@
           <a:prstGeom prst="rect">
             <a:avLst/>
           </a:prstGeom>
-          <a:solidFill>
-            <a:noFill/>
-          </a:solidFill>
+          <a:noFill/>
           <a:ln>
             <a:noFill/>
           </a:ln>
@@ -880,7 +860,7 @@
       <p:sp>
         <p:nvSpPr>
           <p:cNvPr id="2" name="Header"/>
-          <p:cNvPr/>
+          <p:cNvSpPr/>
           <p:nvPr/>
         </p:nvSpPr>
         <p:spPr>
@@ -891,9 +871,7 @@
           <a:prstGeom prst="rect">
             <a:avLst/>
           </a:prstGeom>
-          <a:solidFill>
-            <a:noFill/>
-          </a:solidFill>
+          <a:noFill/>
           <a:ln>
             <a:noFill/>
           </a:ln>
@@ -942,7 +920,7 @@
       <p:sp>
         <p:nvSpPr>
           <p:cNvPr id="3" name="Full"/>
-          <p:cNvPr/>
+          <p:cNvSpPr/>
           <p:nvPr/>
         </p:nvSpPr>
         <p:spPr>
@@ -953,9 +931,7 @@
           <a:prstGeom prst="rect">
             <a:avLst/>
           </a:prstGeom>
-          <a:solidFill>
-            <a:noFill/>
-          </a:solidFill>
+          <a:noFill/>
           <a:ln>
             <a:noFill/>
           </a:ln>
@@ -1017,7 +993,7 @@
       <p:sp>
         <p:nvSpPr>
           <p:cNvPr id="5" name="Footer"/>
-          <p:cNvPr/>
+          <p:cNvSpPr/>
           <p:nvPr/>
         </p:nvSpPr>
         <p:spPr>
@@ -1028,9 +1004,7 @@
           <a:prstGeom prst="rect">
             <a:avLst/>
           </a:prstGeom>
-          <a:solidFill>
-            <a:noFill/>
-          </a:solidFill>
+          <a:noFill/>
           <a:ln>
             <a:noFill/>
           </a:ln>
@@ -1081,7 +1055,7 @@
       <p:sp>
         <p:nvSpPr>
           <p:cNvPr id="2" name="Header"/>
-          <p:cNvPr/>
+          <p:cNvSpPr/>
           <p:nvPr/>
         </p:nvSpPr>
         <p:spPr>
@@ -1092,9 +1066,7 @@
           <a:prstGeom prst="rect">
             <a:avLst/>
           </a:prstGeom>
-          <a:solidFill>
-            <a:noFill/>
-          </a:solidFill>
+          <a:noFill/>
           <a:ln>
             <a:noFill/>
           </a:ln>
@@ -1143,7 +1115,7 @@
       <p:sp>
         <p:nvSpPr>
           <p:cNvPr id="3" name="Full"/>
-          <p:cNvPr/>
+          <p:cNvSpPr/>
           <p:nvPr/>
         </p:nvSpPr>
         <p:spPr>
@@ -1154,9 +1126,7 @@
           <a:prstGeom prst="rect">
             <a:avLst/>
           </a:prstGeom>
-          <a:solidFill>
-            <a:noFill/>
-          </a:solidFill>
+          <a:noFill/>
           <a:ln>
             <a:noFill/>
           </a:ln>
@@ -1254,7 +1224,7 @@
       <p:sp>
         <p:nvSpPr>
           <p:cNvPr id="5" name="Footer"/>
-          <p:cNvPr/>
+          <p:cNvSpPr/>
           <p:nvPr/>
         </p:nvSpPr>
         <p:spPr>
@@ -1265,9 +1235,7 @@
           <a:prstGeom prst="rect">
             <a:avLst/>
           </a:prstGeom>
-          <a:solidFill>
-            <a:noFill/>
-          </a:solidFill>
+          <a:noFill/>
           <a:ln>
             <a:noFill/>
           </a:ln>
@@ -1318,7 +1286,7 @@
       <p:sp>
         <p:nvSpPr>
           <p:cNvPr id="2" name="Header"/>
-          <p:cNvPr/>
+          <p:cNvSpPr/>
           <p:nvPr/>
         </p:nvSpPr>
         <p:spPr>
@@ -1329,9 +1297,7 @@
           <a:prstGeom prst="rect">
             <a:avLst/>
           </a:prstGeom>
-          <a:solidFill>
-            <a:noFill/>
-          </a:solidFill>
+          <a:noFill/>
           <a:ln>
             <a:noFill/>
           </a:ln>
@@ -1380,7 +1346,7 @@
       <p:sp>
         <p:nvSpPr>
           <p:cNvPr id="3" name="Body"/>
-          <p:cNvPr/>
+          <p:cNvSpPr/>
           <p:nvPr/>
         </p:nvSpPr>
         <p:spPr>
@@ -1391,9 +1357,7 @@
           <a:prstGeom prst="rect">
             <a:avLst/>
           </a:prstGeom>
-          <a:solidFill>
-            <a:noFill/>
-          </a:solidFill>
+          <a:noFill/>
           <a:ln>
             <a:noFill/>
           </a:ln>
@@ -1471,7 +1435,7 @@
       <p:sp>
         <p:nvSpPr>
           <p:cNvPr id="4" name="Side"/>
-          <p:cNvPr/>
+          <p:cNvSpPr/>
           <p:nvPr/>
         </p:nvSpPr>
         <p:spPr>
@@ -1482,9 +1446,7 @@
           <a:prstGeom prst="rect">
             <a:avLst/>
           </a:prstGeom>
-          <a:solidFill>
-            <a:noFill/>
-          </a:solidFill>
+          <a:noFill/>
           <a:ln>
             <a:noFill/>
           </a:ln>
@@ -1562,7 +1524,7 @@
       <p:sp>
         <p:nvSpPr>
           <p:cNvPr id="5" name="Footer"/>
-          <p:cNvPr/>
+          <p:cNvSpPr/>
           <p:nvPr/>
         </p:nvSpPr>
         <p:spPr>
@@ -1573,9 +1535,7 @@
           <a:prstGeom prst="rect">
             <a:avLst/>
           </a:prstGeom>
-          <a:solidFill>
-            <a:noFill/>
-          </a:solidFill>
+          <a:noFill/>
           <a:ln>
             <a:noFill/>
           </a:ln>
@@ -1626,7 +1586,7 @@
       <p:sp>
         <p:nvSpPr>
           <p:cNvPr id="2" name="Header"/>
-          <p:cNvPr/>
+          <p:cNvSpPr/>
           <p:nvPr/>
         </p:nvSpPr>
         <p:spPr>
@@ -1637,9 +1597,7 @@
           <a:prstGeom prst="rect">
             <a:avLst/>
           </a:prstGeom>
-          <a:solidFill>
-            <a:noFill/>
-          </a:solidFill>
+          <a:noFill/>
           <a:ln>
             <a:noFill/>
           </a:ln>
@@ -1688,7 +1646,7 @@
       <p:sp>
         <p:nvSpPr>
           <p:cNvPr id="3" name="Full"/>
-          <p:cNvPr/>
+          <p:cNvSpPr/>
           <p:nvPr/>
         </p:nvSpPr>
         <p:spPr>
@@ -1699,9 +1657,7 @@
           <a:prstGeom prst="rect">
             <a:avLst/>
           </a:prstGeom>
-          <a:solidFill>
-            <a:noFill/>
-          </a:solidFill>
+          <a:noFill/>
           <a:ln>
             <a:noFill/>
           </a:ln>
@@ -1776,7 +1732,7 @@
       <p:sp>
         <p:nvSpPr>
           <p:cNvPr id="5" name="Footer"/>
-          <p:cNvPr/>
+          <p:cNvSpPr/>
           <p:nvPr/>
         </p:nvSpPr>
         <p:spPr>
@@ -1787,9 +1743,7 @@
           <a:prstGeom prst="rect">
             <a:avLst/>
           </a:prstGeom>
-          <a:solidFill>
-            <a:noFill/>
-          </a:solidFill>
+          <a:noFill/>
           <a:ln>
             <a:noFill/>
           </a:ln>
@@ -1840,7 +1794,7 @@
       <p:sp>
         <p:nvSpPr>
           <p:cNvPr id="2" name="Header"/>
-          <p:cNvPr/>
+          <p:cNvSpPr/>
           <p:nvPr/>
         </p:nvSpPr>
         <p:spPr>
@@ -1851,9 +1805,7 @@
           <a:prstGeom prst="rect">
             <a:avLst/>
           </a:prstGeom>
-          <a:solidFill>
-            <a:noFill/>
-          </a:solidFill>
+          <a:noFill/>
           <a:ln>
             <a:noFill/>
           </a:ln>
@@ -1902,7 +1854,7 @@
       <p:sp>
         <p:nvSpPr>
           <p:cNvPr id="3" name="Full"/>
-          <p:cNvPr/>
+          <p:cNvSpPr/>
           <p:nvPr/>
         </p:nvSpPr>
         <p:spPr>
@@ -1913,9 +1865,7 @@
           <a:prstGeom prst="rect">
             <a:avLst/>
           </a:prstGeom>
-          <a:solidFill>
-            <a:noFill/>
-          </a:solidFill>
+          <a:noFill/>
           <a:ln>
             <a:noFill/>
           </a:ln>
@@ -2010,7 +1960,7 @@
       <p:sp>
         <p:nvSpPr>
           <p:cNvPr id="5" name="Footer"/>
-          <p:cNvPr/>
+          <p:cNvSpPr/>
           <p:nvPr/>
         </p:nvSpPr>
         <p:spPr>
@@ -2021,9 +1971,7 @@
           <a:prstGeom prst="rect">
             <a:avLst/>
           </a:prstGeom>
-          <a:solidFill>
-            <a:noFill/>
-          </a:solidFill>
+          <a:noFill/>
           <a:ln>
             <a:noFill/>
           </a:ln>
@@ -2074,7 +2022,7 @@
       <p:sp>
         <p:nvSpPr>
           <p:cNvPr id="2" name="Header"/>
-          <p:cNvPr/>
+          <p:cNvSpPr/>
           <p:nvPr/>
         </p:nvSpPr>
         <p:spPr>
@@ -2085,9 +2033,7 @@
           <a:prstGeom prst="rect">
             <a:avLst/>
           </a:prstGeom>
-          <a:solidFill>
-            <a:noFill/>
-          </a:solidFill>
+          <a:noFill/>
           <a:ln>
             <a:noFill/>
           </a:ln>
@@ -2136,7 +2082,7 @@
       <p:sp>
         <p:nvSpPr>
           <p:cNvPr id="3" name="Full"/>
-          <p:cNvPr/>
+          <p:cNvSpPr/>
           <p:nvPr/>
         </p:nvSpPr>
         <p:spPr>
@@ -2147,9 +2093,7 @@
           <a:prstGeom prst="rect">
             <a:avLst/>
           </a:prstGeom>
-          <a:solidFill>
-            <a:noFill/>
-          </a:solidFill>
+          <a:noFill/>
           <a:ln>
             <a:noFill/>
           </a:ln>
@@ -2221,7 +2165,7 @@
       <p:sp>
         <p:nvSpPr>
           <p:cNvPr id="5" name="Footer"/>
-          <p:cNvPr/>
+          <p:cNvSpPr/>
           <p:nvPr/>
         </p:nvSpPr>
         <p:spPr>
@@ -2232,9 +2176,7 @@
           <a:prstGeom prst="rect">
             <a:avLst/>
           </a:prstGeom>
-          <a:solidFill>
-            <a:noFill/>
-          </a:solidFill>
+          <a:noFill/>
           <a:ln>
             <a:noFill/>
           </a:ln>
@@ -2285,7 +2227,7 @@
       <p:sp>
         <p:nvSpPr>
           <p:cNvPr id="2" name="Header"/>
-          <p:cNvPr/>
+          <p:cNvSpPr/>
           <p:nvPr/>
         </p:nvSpPr>
         <p:spPr>
@@ -2296,9 +2238,7 @@
           <a:prstGeom prst="rect">
             <a:avLst/>
           </a:prstGeom>
-          <a:solidFill>
-            <a:noFill/>
-          </a:solidFill>
+          <a:noFill/>
           <a:ln>
             <a:noFill/>
           </a:ln>
@@ -2347,7 +2287,7 @@
       <p:sp>
         <p:nvSpPr>
           <p:cNvPr id="3" name="Full"/>
-          <p:cNvPr/>
+          <p:cNvSpPr/>
           <p:nvPr/>
         </p:nvSpPr>
         <p:spPr>
@@ -2358,9 +2298,7 @@
           <a:prstGeom prst="rect">
             <a:avLst/>
           </a:prstGeom>
-          <a:solidFill>
-            <a:noFill/>
-          </a:solidFill>
+          <a:noFill/>
           <a:ln>
             <a:noFill/>
           </a:ln>
@@ -2474,7 +2412,7 @@
       <p:sp>
         <p:nvSpPr>
           <p:cNvPr id="5" name="Footer"/>
-          <p:cNvPr/>
+          <p:cNvSpPr/>
           <p:nvPr/>
         </p:nvSpPr>
         <p:spPr>
@@ -2485,9 +2423,7 @@
           <a:prstGeom prst="rect">
             <a:avLst/>
           </a:prstGeom>
-          <a:solidFill>
-            <a:noFill/>
-          </a:solidFill>
+          <a:noFill/>
           <a:ln>
             <a:noFill/>
           </a:ln>
@@ -2538,7 +2474,7 @@
       <p:sp>
         <p:nvSpPr>
           <p:cNvPr id="2" name="Header"/>
-          <p:cNvPr/>
+          <p:cNvSpPr/>
           <p:nvPr/>
         </p:nvSpPr>
         <p:spPr>
@@ -2549,9 +2485,7 @@
           <a:prstGeom prst="rect">
             <a:avLst/>
           </a:prstGeom>
-          <a:solidFill>
-            <a:noFill/>
-          </a:solidFill>
+          <a:noFill/>
           <a:ln>
             <a:noFill/>
           </a:ln>
@@ -2600,7 +2534,7 @@
       <p:sp>
         <p:nvSpPr>
           <p:cNvPr id="3" name="Body"/>
-          <p:cNvPr/>
+          <p:cNvSpPr/>
           <p:nvPr/>
         </p:nvSpPr>
         <p:spPr>
@@ -2611,9 +2545,7 @@
           <a:prstGeom prst="rect">
             <a:avLst/>
           </a:prstGeom>
-          <a:solidFill>
-            <a:noFill/>
-          </a:solidFill>
+          <a:noFill/>
           <a:ln>
             <a:noFill/>
           </a:ln>
@@ -2726,7 +2658,7 @@
       <p:sp>
         <p:nvSpPr>
           <p:cNvPr id="4" name="Side"/>
-          <p:cNvPr/>
+          <p:cNvSpPr/>
           <p:nvPr/>
         </p:nvSpPr>
         <p:spPr>
@@ -2737,9 +2669,7 @@
           <a:prstGeom prst="rect">
             <a:avLst/>
           </a:prstGeom>
-          <a:solidFill>
-            <a:noFill/>
-          </a:solidFill>
+          <a:noFill/>
           <a:ln>
             <a:noFill/>
           </a:ln>
@@ -2812,7 +2742,7 @@
       <p:sp>
         <p:nvSpPr>
           <p:cNvPr id="5" name="Footer"/>
-          <p:cNvPr/>
+          <p:cNvSpPr/>
           <p:nvPr/>
         </p:nvSpPr>
         <p:spPr>
@@ -2823,9 +2753,7 @@
           <a:prstGeom prst="rect">
             <a:avLst/>
           </a:prstGeom>
-          <a:solidFill>
-            <a:noFill/>
-          </a:solidFill>
+          <a:noFill/>
           <a:ln>
             <a:noFill/>
           </a:ln>
@@ -2876,7 +2804,7 @@
       <p:sp>
         <p:nvSpPr>
           <p:cNvPr id="2" name="Header"/>
-          <p:cNvPr/>
+          <p:cNvSpPr/>
           <p:nvPr/>
         </p:nvSpPr>
         <p:spPr>
@@ -2887,9 +2815,7 @@
           <a:prstGeom prst="rect">
             <a:avLst/>
           </a:prstGeom>
-          <a:solidFill>
-            <a:noFill/>
-          </a:solidFill>
+          <a:noFill/>
           <a:ln>
             <a:noFill/>
           </a:ln>
@@ -2938,7 +2864,7 @@
       <p:sp>
         <p:nvSpPr>
           <p:cNvPr id="3" name="Body"/>
-          <p:cNvPr/>
+          <p:cNvSpPr/>
           <p:nvPr/>
         </p:nvSpPr>
         <p:spPr>
@@ -2949,9 +2875,7 @@
           <a:prstGeom prst="rect">
             <a:avLst/>
           </a:prstGeom>
-          <a:solidFill>
-            <a:noFill/>
-          </a:solidFill>
+          <a:noFill/>
           <a:ln>
             <a:noFill/>
           </a:ln>
@@ -3062,7 +2986,7 @@
       <p:sp>
         <p:nvSpPr>
           <p:cNvPr id="4" name="Side"/>
-          <p:cNvPr/>
+          <p:cNvSpPr/>
           <p:nvPr/>
         </p:nvSpPr>
         <p:spPr>
@@ -3073,9 +2997,7 @@
           <a:prstGeom prst="rect">
             <a:avLst/>
           </a:prstGeom>
-          <a:solidFill>
-            <a:noFill/>
-          </a:solidFill>
+          <a:noFill/>
           <a:ln>
             <a:noFill/>
           </a:ln>
@@ -3174,7 +3096,7 @@
       <p:sp>
         <p:nvSpPr>
           <p:cNvPr id="5" name="Footer"/>
-          <p:cNvPr/>
+          <p:cNvSpPr/>
           <p:nvPr/>
         </p:nvSpPr>
         <p:spPr>
@@ -3185,9 +3107,7 @@
           <a:prstGeom prst="rect">
             <a:avLst/>
           </a:prstGeom>
-          <a:solidFill>
-            <a:noFill/>
-          </a:solidFill>
+          <a:noFill/>
           <a:ln>
             <a:noFill/>
           </a:ln>
@@ -3238,7 +3158,7 @@
       <p:sp>
         <p:nvSpPr>
           <p:cNvPr id="2" name="Header"/>
-          <p:cNvPr/>
+          <p:cNvSpPr/>
           <p:nvPr/>
         </p:nvSpPr>
         <p:spPr>
@@ -3249,9 +3169,7 @@
           <a:prstGeom prst="rect">
             <a:avLst/>
           </a:prstGeom>
-          <a:solidFill>
-            <a:noFill/>
-          </a:solidFill>
+          <a:noFill/>
           <a:ln>
             <a:noFill/>
           </a:ln>
@@ -3300,7 +3218,7 @@
       <p:sp>
         <p:nvSpPr>
           <p:cNvPr id="3" name="Body"/>
-          <p:cNvPr/>
+          <p:cNvSpPr/>
           <p:nvPr/>
         </p:nvSpPr>
         <p:spPr>
@@ -3311,9 +3229,7 @@
           <a:prstGeom prst="rect">
             <a:avLst/>
           </a:prstGeom>
-          <a:solidFill>
-            <a:noFill/>
-          </a:solidFill>
+          <a:noFill/>
           <a:ln>
             <a:noFill/>
           </a:ln>
@@ -3400,7 +3316,7 @@
       <p:sp>
         <p:nvSpPr>
           <p:cNvPr id="4" name="Side"/>
-          <p:cNvPr/>
+          <p:cNvSpPr/>
           <p:nvPr/>
         </p:nvSpPr>
         <p:spPr>
@@ -3411,9 +3327,7 @@
           <a:prstGeom prst="rect">
             <a:avLst/>
           </a:prstGeom>
-          <a:solidFill>
-            <a:noFill/>
-          </a:solidFill>
+          <a:noFill/>
           <a:ln>
             <a:noFill/>
           </a:ln>
@@ -3500,7 +3414,7 @@
       <p:sp>
         <p:nvSpPr>
           <p:cNvPr id="5" name="Footer"/>
-          <p:cNvPr/>
+          <p:cNvSpPr/>
           <p:nvPr/>
         </p:nvSpPr>
         <p:spPr>
@@ -3511,9 +3425,7 @@
           <a:prstGeom prst="rect">
             <a:avLst/>
           </a:prstGeom>
-          <a:solidFill>
-            <a:noFill/>
-          </a:solidFill>
+          <a:noFill/>
           <a:ln>
             <a:noFill/>
           </a:ln>
@@ -3564,7 +3476,7 @@
       <p:sp>
         <p:nvSpPr>
           <p:cNvPr id="2" name="Header"/>
-          <p:cNvPr/>
+          <p:cNvSpPr/>
           <p:nvPr/>
         </p:nvSpPr>
         <p:spPr>
@@ -3575,9 +3487,7 @@
           <a:prstGeom prst="rect">
             <a:avLst/>
           </a:prstGeom>
-          <a:solidFill>
-            <a:noFill/>
-          </a:solidFill>
+          <a:noFill/>
           <a:ln>
             <a:noFill/>
           </a:ln>
@@ -3626,7 +3536,7 @@
       <p:sp>
         <p:nvSpPr>
           <p:cNvPr id="3" name="Full"/>
-          <p:cNvPr/>
+          <p:cNvSpPr/>
           <p:nvPr/>
         </p:nvSpPr>
         <p:spPr>
@@ -3637,9 +3547,7 @@
           <a:prstGeom prst="rect">
             <a:avLst/>
           </a:prstGeom>
-          <a:solidFill>
-            <a:noFill/>
-          </a:solidFill>
+          <a:noFill/>
           <a:ln>
             <a:noFill/>
           </a:ln>
@@ -3711,7 +3619,7 @@
       <p:sp>
         <p:nvSpPr>
           <p:cNvPr id="5" name="Footer"/>
-          <p:cNvPr/>
+          <p:cNvSpPr/>
           <p:nvPr/>
         </p:nvSpPr>
         <p:spPr>
@@ -3722,9 +3630,7 @@
           <a:prstGeom prst="rect">
             <a:avLst/>
           </a:prstGeom>
-          <a:solidFill>
-            <a:noFill/>
-          </a:solidFill>
+          <a:noFill/>
           <a:ln>
             <a:noFill/>
           </a:ln>
@@ -3775,7 +3681,7 @@
       <p:sp>
         <p:nvSpPr>
           <p:cNvPr id="2" name="Header"/>
-          <p:cNvPr/>
+          <p:cNvSpPr/>
           <p:nvPr/>
         </p:nvSpPr>
         <p:spPr>
@@ -3786,9 +3692,7 @@
           <a:prstGeom prst="rect">
             <a:avLst/>
           </a:prstGeom>
-          <a:solidFill>
-            <a:noFill/>
-          </a:solidFill>
+          <a:noFill/>
           <a:ln>
             <a:noFill/>
           </a:ln>
@@ -3837,7 +3741,7 @@
       <p:sp>
         <p:nvSpPr>
           <p:cNvPr id="3" name="Body"/>
-          <p:cNvPr/>
+          <p:cNvSpPr/>
           <p:nvPr/>
         </p:nvSpPr>
         <p:spPr>
@@ -3848,9 +3752,7 @@
           <a:prstGeom prst="rect">
             <a:avLst/>
           </a:prstGeom>
-          <a:solidFill>
-            <a:noFill/>
-          </a:solidFill>
+          <a:noFill/>
           <a:ln>
             <a:noFill/>
           </a:ln>
@@ -3925,7 +3827,7 @@
       <p:sp>
         <p:nvSpPr>
           <p:cNvPr id="4" name="Side"/>
-          <p:cNvPr/>
+          <p:cNvSpPr/>
           <p:nvPr/>
         </p:nvSpPr>
         <p:spPr>
@@ -3936,9 +3838,7 @@
           <a:prstGeom prst="rect">
             <a:avLst/>
           </a:prstGeom>
-          <a:solidFill>
-            <a:noFill/>
-          </a:solidFill>
+          <a:noFill/>
           <a:ln>
             <a:noFill/>
           </a:ln>
@@ -4000,7 +3900,7 @@
       <p:sp>
         <p:nvSpPr>
           <p:cNvPr id="5" name="Footer"/>
-          <p:cNvPr/>
+          <p:cNvSpPr/>
           <p:nvPr/>
         </p:nvSpPr>
         <p:spPr>
@@ -4011,9 +3911,7 @@
           <a:prstGeom prst="rect">
             <a:avLst/>
           </a:prstGeom>
-          <a:solidFill>
-            <a:noFill/>
-          </a:solidFill>
+          <a:noFill/>
           <a:ln>
             <a:noFill/>
           </a:ln>
@@ -4064,7 +3962,7 @@
       <p:sp>
         <p:nvSpPr>
           <p:cNvPr id="2" name="Header"/>
-          <p:cNvPr/>
+          <p:cNvSpPr/>
           <p:nvPr/>
         </p:nvSpPr>
         <p:spPr>
@@ -4075,9 +3973,7 @@
           <a:prstGeom prst="rect">
             <a:avLst/>
           </a:prstGeom>
-          <a:solidFill>
-            <a:noFill/>
-          </a:solidFill>
+          <a:noFill/>
           <a:ln>
             <a:noFill/>
           </a:ln>
@@ -4126,7 +4022,7 @@
       <p:sp>
         <p:nvSpPr>
           <p:cNvPr id="3" name="Body"/>
-          <p:cNvPr/>
+          <p:cNvSpPr/>
           <p:nvPr/>
         </p:nvSpPr>
         <p:spPr>
@@ -4137,9 +4033,7 @@
           <a:prstGeom prst="rect">
             <a:avLst/>
           </a:prstGeom>
-          <a:solidFill>
-            <a:noFill/>
-          </a:solidFill>
+          <a:noFill/>
           <a:ln>
             <a:noFill/>
           </a:ln>
@@ -4227,7 +4121,7 @@
       <p:sp>
         <p:nvSpPr>
           <p:cNvPr id="4" name="Side"/>
-          <p:cNvPr/>
+          <p:cNvSpPr/>
           <p:nvPr/>
         </p:nvSpPr>
         <p:spPr>
@@ -4238,9 +4132,7 @@
           <a:prstGeom prst="rect">
             <a:avLst/>
           </a:prstGeom>
-          <a:solidFill>
-            <a:noFill/>
-          </a:solidFill>
+          <a:noFill/>
           <a:ln>
             <a:noFill/>
           </a:ln>
@@ -4302,7 +4194,7 @@
       <p:sp>
         <p:nvSpPr>
           <p:cNvPr id="5" name="Footer"/>
-          <p:cNvPr/>
+          <p:cNvSpPr/>
           <p:nvPr/>
         </p:nvSpPr>
         <p:spPr>
@@ -4313,9 +4205,7 @@
           <a:prstGeom prst="rect">
             <a:avLst/>
           </a:prstGeom>
-          <a:solidFill>
-            <a:noFill/>
-          </a:solidFill>
+          <a:noFill/>
           <a:ln>
             <a:noFill/>
           </a:ln>
@@ -4366,7 +4256,7 @@
       <p:sp>
         <p:nvSpPr>
           <p:cNvPr id="2" name="Header"/>
-          <p:cNvPr/>
+          <p:cNvSpPr/>
           <p:nvPr/>
         </p:nvSpPr>
         <p:spPr>
@@ -4377,9 +4267,7 @@
           <a:prstGeom prst="rect">
             <a:avLst/>
           </a:prstGeom>
-          <a:solidFill>
-            <a:noFill/>
-          </a:solidFill>
+          <a:noFill/>
           <a:ln>
             <a:noFill/>
           </a:ln>
@@ -4428,7 +4316,7 @@
       <p:sp>
         <p:nvSpPr>
           <p:cNvPr id="3" name="Body"/>
-          <p:cNvPr/>
+          <p:cNvSpPr/>
           <p:nvPr/>
         </p:nvSpPr>
         <p:spPr>
@@ -4439,9 +4327,7 @@
           <a:prstGeom prst="rect">
             <a:avLst/>
           </a:prstGeom>
-          <a:solidFill>
-            <a:noFill/>
-          </a:solidFill>
+          <a:noFill/>
           <a:ln>
             <a:noFill/>
           </a:ln>
@@ -4540,7 +4426,7 @@
       <p:sp>
         <p:nvSpPr>
           <p:cNvPr id="4" name="Side"/>
-          <p:cNvPr/>
+          <p:cNvSpPr/>
           <p:nvPr/>
         </p:nvSpPr>
         <p:spPr>
@@ -4551,9 +4437,7 @@
           <a:prstGeom prst="rect">
             <a:avLst/>
           </a:prstGeom>
-          <a:solidFill>
-            <a:noFill/>
-          </a:solidFill>
+          <a:noFill/>
           <a:ln>
             <a:noFill/>
           </a:ln>
@@ -4630,7 +4514,7 @@
       <p:sp>
         <p:nvSpPr>
           <p:cNvPr id="5" name="Footer"/>
-          <p:cNvPr/>
+          <p:cNvSpPr/>
           <p:nvPr/>
         </p:nvSpPr>
         <p:spPr>
@@ -4641,9 +4525,7 @@
           <a:prstGeom prst="rect">
             <a:avLst/>
           </a:prstGeom>
-          <a:solidFill>
-            <a:noFill/>
-          </a:solidFill>
+          <a:noFill/>
           <a:ln>
             <a:noFill/>
           </a:ln>
@@ -4694,7 +4576,7 @@
       <p:sp>
         <p:nvSpPr>
           <p:cNvPr id="2" name="Header"/>
-          <p:cNvPr/>
+          <p:cNvSpPr/>
           <p:nvPr/>
         </p:nvSpPr>
         <p:spPr>
@@ -4705,9 +4587,7 @@
           <a:prstGeom prst="rect">
             <a:avLst/>
           </a:prstGeom>
-          <a:solidFill>
-            <a:noFill/>
-          </a:solidFill>
+          <a:noFill/>
           <a:ln>
             <a:noFill/>
           </a:ln>
@@ -4756,7 +4636,7 @@
       <p:sp>
         <p:nvSpPr>
           <p:cNvPr id="3" name="Body"/>
-          <p:cNvPr/>
+          <p:cNvSpPr/>
           <p:nvPr/>
         </p:nvSpPr>
         <p:spPr>
@@ -4767,9 +4647,7 @@
           <a:prstGeom prst="rect">
             <a:avLst/>
           </a:prstGeom>
-          <a:solidFill>
-            <a:noFill/>
-          </a:solidFill>
+          <a:noFill/>
           <a:ln>
             <a:noFill/>
           </a:ln>
@@ -4844,7 +4722,7 @@
       <p:sp>
         <p:nvSpPr>
           <p:cNvPr id="4" name="Side"/>
-          <p:cNvPr/>
+          <p:cNvSpPr/>
           <p:nvPr/>
         </p:nvSpPr>
         <p:spPr>
@@ -4855,9 +4733,7 @@
           <a:prstGeom prst="rect">
             <a:avLst/>
           </a:prstGeom>
-          <a:solidFill>
-            <a:noFill/>
-          </a:solidFill>
+          <a:noFill/>
           <a:ln>
             <a:noFill/>
           </a:ln>
@@ -4920,7 +4796,7 @@
       <p:sp>
         <p:nvSpPr>
           <p:cNvPr id="5" name="Footer"/>
-          <p:cNvPr/>
+          <p:cNvSpPr/>
           <p:nvPr/>
         </p:nvSpPr>
         <p:spPr>
@@ -4931,9 +4807,7 @@
           <a:prstGeom prst="rect">
             <a:avLst/>
           </a:prstGeom>
-          <a:solidFill>
-            <a:noFill/>
-          </a:solidFill>
+          <a:noFill/>
           <a:ln>
             <a:noFill/>
           </a:ln>

</xml_diff>

<commit_message>
fix: PPTX opens in PowerPoint — theme now ECMA-376 strict (3-entry style lists, fontScheme ea/cs), correct footer URL, drop dead code
</commit_message>
<xml_diff>
--- a/slides/rag_explainer.pptx
+++ b/slides/rag_explainer.pptx
@@ -201,7 +201,7 @@
                   <a:srgbClr val="5A6C80"/>
                 </a:solidFill>
               </a:rPr>
-              <a:t>TCS France  •  RAG Explainer  •  Private data stays private  •  rag-explainer.github.io</a:t>
+              <a:t>RAG Explainer  •  Private data stays private  •  uiyuvi.github.io/rag-explainer</a:t>
             </a:r>
           </a:p>
         </p:txBody>
@@ -544,7 +544,7 @@
                   <a:srgbClr val="5A6C80"/>
                 </a:solidFill>
               </a:rPr>
-              <a:t>TCS France  •  RAG Explainer  •  Private data stays private  •  rag-explainer.github.io</a:t>
+              <a:t>RAG Explainer  •  Private data stays private  •  uiyuvi.github.io/rag-explainer</a:t>
             </a:r>
           </a:p>
         </p:txBody>
@@ -827,7 +827,7 @@
                   <a:srgbClr val="5A6C80"/>
                 </a:solidFill>
               </a:rPr>
-              <a:t>TCS France  •  RAG Explainer  •  Private data stays private  •  rag-explainer.github.io</a:t>
+              <a:t>RAG Explainer  •  Private data stays private  •  uiyuvi.github.io/rag-explainer</a:t>
             </a:r>
           </a:p>
         </p:txBody>
@@ -1022,7 +1022,7 @@
                   <a:srgbClr val="5A6C80"/>
                 </a:solidFill>
               </a:rPr>
-              <a:t>TCS France  •  RAG Explainer  •  Private data stays private  •  rag-explainer.github.io</a:t>
+              <a:t>RAG Explainer  •  Private data stays private  •  uiyuvi.github.io/rag-explainer</a:t>
             </a:r>
           </a:p>
         </p:txBody>
@@ -1253,7 +1253,7 @@
                   <a:srgbClr val="5A6C80"/>
                 </a:solidFill>
               </a:rPr>
-              <a:t>TCS France  •  RAG Explainer  •  Private data stays private  •  rag-explainer.github.io</a:t>
+              <a:t>RAG Explainer  •  Private data stays private  •  uiyuvi.github.io/rag-explainer</a:t>
             </a:r>
           </a:p>
         </p:txBody>
@@ -1553,7 +1553,7 @@
                   <a:srgbClr val="5A6C80"/>
                 </a:solidFill>
               </a:rPr>
-              <a:t>TCS France  •  RAG Explainer  •  Private data stays private  •  rag-explainer.github.io</a:t>
+              <a:t>RAG Explainer  •  Private data stays private  •  uiyuvi.github.io/rag-explainer</a:t>
             </a:r>
           </a:p>
         </p:txBody>
@@ -1761,7 +1761,7 @@
                   <a:srgbClr val="5A6C80"/>
                 </a:solidFill>
               </a:rPr>
-              <a:t>TCS France  •  RAG Explainer  •  Private data stays private  •  rag-explainer.github.io</a:t>
+              <a:t>RAG Explainer  •  Private data stays private  •  uiyuvi.github.io/rag-explainer</a:t>
             </a:r>
           </a:p>
         </p:txBody>
@@ -1989,7 +1989,7 @@
                   <a:srgbClr val="5A6C80"/>
                 </a:solidFill>
               </a:rPr>
-              <a:t>TCS France  •  RAG Explainer  •  Private data stays private  •  rag-explainer.github.io</a:t>
+              <a:t>RAG Explainer  •  Private data stays private  •  uiyuvi.github.io/rag-explainer</a:t>
             </a:r>
           </a:p>
         </p:txBody>
@@ -2194,7 +2194,7 @@
                   <a:srgbClr val="5A6C80"/>
                 </a:solidFill>
               </a:rPr>
-              <a:t>TCS France  •  RAG Explainer  •  Private data stays private  •  rag-explainer.github.io</a:t>
+              <a:t>RAG Explainer  •  Private data stays private  •  uiyuvi.github.io/rag-explainer</a:t>
             </a:r>
           </a:p>
         </p:txBody>
@@ -2441,7 +2441,7 @@
                   <a:srgbClr val="5A6C80"/>
                 </a:solidFill>
               </a:rPr>
-              <a:t>TCS France  •  RAG Explainer  •  Private data stays private  •  rag-explainer.github.io</a:t>
+              <a:t>RAG Explainer  •  Private data stays private  •  uiyuvi.github.io/rag-explainer</a:t>
             </a:r>
           </a:p>
         </p:txBody>
@@ -2771,7 +2771,7 @@
                   <a:srgbClr val="5A6C80"/>
                 </a:solidFill>
               </a:rPr>
-              <a:t>TCS France  •  RAG Explainer  •  Private data stays private  •  rag-explainer.github.io</a:t>
+              <a:t>RAG Explainer  •  Private data stays private  •  uiyuvi.github.io/rag-explainer</a:t>
             </a:r>
           </a:p>
         </p:txBody>
@@ -3125,7 +3125,7 @@
                   <a:srgbClr val="5A6C80"/>
                 </a:solidFill>
               </a:rPr>
-              <a:t>TCS France  •  RAG Explainer  •  Private data stays private  •  rag-explainer.github.io</a:t>
+              <a:t>RAG Explainer  •  Private data stays private  •  uiyuvi.github.io/rag-explainer</a:t>
             </a:r>
           </a:p>
         </p:txBody>
@@ -3443,7 +3443,7 @@
                   <a:srgbClr val="5A6C80"/>
                 </a:solidFill>
               </a:rPr>
-              <a:t>TCS France  •  RAG Explainer  •  Private data stays private  •  rag-explainer.github.io</a:t>
+              <a:t>RAG Explainer  •  Private data stays private  •  uiyuvi.github.io/rag-explainer</a:t>
             </a:r>
           </a:p>
         </p:txBody>
@@ -3648,7 +3648,7 @@
                   <a:srgbClr val="5A6C80"/>
                 </a:solidFill>
               </a:rPr>
-              <a:t>TCS France  •  RAG Explainer  •  Private data stays private  •  rag-explainer.github.io</a:t>
+              <a:t>RAG Explainer  •  Private data stays private  •  uiyuvi.github.io/rag-explainer</a:t>
             </a:r>
           </a:p>
         </p:txBody>
@@ -3929,7 +3929,7 @@
                   <a:srgbClr val="5A6C80"/>
                 </a:solidFill>
               </a:rPr>
-              <a:t>TCS France  •  RAG Explainer  •  Private data stays private  •  rag-explainer.github.io</a:t>
+              <a:t>RAG Explainer  •  Private data stays private  •  uiyuvi.github.io/rag-explainer</a:t>
             </a:r>
           </a:p>
         </p:txBody>
@@ -4223,7 +4223,7 @@
                   <a:srgbClr val="5A6C80"/>
                 </a:solidFill>
               </a:rPr>
-              <a:t>TCS France  •  RAG Explainer  •  Private data stays private  •  rag-explainer.github.io</a:t>
+              <a:t>RAG Explainer  •  Private data stays private  •  uiyuvi.github.io/rag-explainer</a:t>
             </a:r>
           </a:p>
         </p:txBody>
@@ -4543,7 +4543,7 @@
                   <a:srgbClr val="5A6C80"/>
                 </a:solidFill>
               </a:rPr>
-              <a:t>TCS France  •  RAG Explainer  •  Private data stays private  •  rag-explainer.github.io</a:t>
+              <a:t>RAG Explainer  •  Private data stays private  •  uiyuvi.github.io/rag-explainer</a:t>
             </a:r>
           </a:p>
         </p:txBody>
@@ -4825,7 +4825,7 @@
                   <a:srgbClr val="5A6C80"/>
                 </a:solidFill>
               </a:rPr>
-              <a:t>TCS France  •  RAG Explainer  •  Private data stays private  •  rag-explainer.github.io</a:t>
+              <a:t>RAG Explainer  •  Private data stays private  •  uiyuvi.github.io/rag-explainer</a:t>
             </a:r>
           </a:p>
         </p:txBody>
@@ -4839,9 +4839,9 @@
 </file>
 
 <file path=ppt/theme/theme1.xml><?xml version="1.0" encoding="utf-8"?>
-<a:theme xmlns:a="http://schemas.openxmlformats.org/drawingml/2006/main" name="TCS France">
+<a:theme xmlns:a="http://schemas.openxmlformats.org/drawingml/2006/main" name="RAG Explainer">
   <a:themeElements>
-    <a:clrScheme name="TCS">
+    <a:clrScheme name="RAGExplainer">
       <a:dk1>
         <a:srgbClr val="0A1931"/>
       </a:dk1>
@@ -4879,37 +4879,153 @@
         <a:srgbClr val="0A1931"/>
       </a:folHlink>
     </a:clrScheme>
-    <a:fontScheme name="TCS">
+    <a:fontScheme name="RAGExplainer">
       <a:majorFont>
-        <a:latin typeface="Calibri"/>
+        <a:latin typeface="Calibri Light"/>
+        <a:ea typeface=""/>
+        <a:cs typeface=""/>
       </a:majorFont>
       <a:minorFont>
         <a:latin typeface="Calibri"/>
+        <a:ea typeface=""/>
+        <a:cs typeface=""/>
       </a:minorFont>
     </a:fontScheme>
-    <a:fmtScheme name="TCS">
+    <a:fmtScheme name="RAGExplainer">
       <a:fillStyleLst>
         <a:solidFill>
           <a:schemeClr val="phClr"/>
         </a:solidFill>
+        <a:gradFill rotWithShape="1">
+          <a:gsLst>
+            <a:gs pos="0">
+              <a:schemeClr val="phClr">
+                <a:lumMod val="110000"/>
+                <a:satMod val="105000"/>
+                <a:tint val="67000"/>
+              </a:schemeClr>
+            </a:gs>
+            <a:gs pos="50000">
+              <a:schemeClr val="phClr">
+                <a:lumMod val="105000"/>
+                <a:satMod val="103000"/>
+                <a:tint val="73000"/>
+              </a:schemeClr>
+            </a:gs>
+            <a:gs pos="100000">
+              <a:schemeClr val="phClr">
+                <a:lumMod val="105000"/>
+                <a:satMod val="109000"/>
+                <a:tint val="81000"/>
+              </a:schemeClr>
+            </a:gs>
+          </a:gsLst>
+          <a:lin ang="5400000" scaled="0"/>
+        </a:gradFill>
+        <a:gradFill rotWithShape="1">
+          <a:gsLst>
+            <a:gs pos="0">
+              <a:schemeClr val="phClr">
+                <a:satMod val="103000"/>
+                <a:lumMod val="102000"/>
+                <a:tint val="94000"/>
+              </a:schemeClr>
+            </a:gs>
+            <a:gs pos="50000">
+              <a:schemeClr val="phClr">
+                <a:satMod val="110000"/>
+                <a:lumMod val="100000"/>
+                <a:shade val="100000"/>
+              </a:schemeClr>
+            </a:gs>
+            <a:gs pos="100000">
+              <a:schemeClr val="phClr">
+                <a:lumMod val="99000"/>
+                <a:satMod val="120000"/>
+                <a:shade val="78000"/>
+              </a:schemeClr>
+            </a:gs>
+          </a:gsLst>
+          <a:lin ang="5400000" scaled="0"/>
+        </a:gradFill>
       </a:fillStyleLst>
       <a:lnStyleLst>
-        <a:ln w="6350">
+        <a:ln w="6350" cap="flat" cmpd="sng" algn="ctr">
           <a:solidFill>
             <a:schemeClr val="phClr"/>
           </a:solidFill>
           <a:prstDash val="solid"/>
+          <a:miter lim="800000"/>
+        </a:ln>
+        <a:ln w="12700" cap="flat" cmpd="sng" algn="ctr">
+          <a:solidFill>
+            <a:schemeClr val="phClr"/>
+          </a:solidFill>
+          <a:prstDash val="solid"/>
+          <a:miter lim="800000"/>
+        </a:ln>
+        <a:ln w="19050" cap="flat" cmpd="sng" algn="ctr">
+          <a:solidFill>
+            <a:schemeClr val="phClr"/>
+          </a:solidFill>
+          <a:prstDash val="solid"/>
+          <a:miter lim="800000"/>
         </a:ln>
       </a:lnStyleLst>
       <a:effectStyleLst>
         <a:effectStyle>
           <a:effectLst/>
         </a:effectStyle>
+        <a:effectStyle>
+          <a:effectLst/>
+        </a:effectStyle>
+        <a:effectStyle>
+          <a:effectLst>
+            <a:outerShdw blurRad="57150" dist="19050" dir="5400000" algn="ctr" rotWithShape="0">
+              <a:srgbClr val="000000">
+                <a:alpha val="63000"/>
+              </a:srgbClr>
+            </a:outerShdw>
+          </a:effectLst>
+        </a:effectStyle>
       </a:effectStyleLst>
       <a:bgFillStyleLst>
         <a:solidFill>
           <a:schemeClr val="phClr"/>
         </a:solidFill>
+        <a:solidFill>
+          <a:schemeClr val="phClr">
+            <a:tint val="95000"/>
+            <a:satMod val="170000"/>
+          </a:schemeClr>
+        </a:solidFill>
+        <a:gradFill rotWithShape="1">
+          <a:gsLst>
+            <a:gs pos="0">
+              <a:schemeClr val="phClr">
+                <a:tint val="93000"/>
+                <a:satMod val="150000"/>
+                <a:shade val="98000"/>
+                <a:lumMod val="102000"/>
+              </a:schemeClr>
+            </a:gs>
+            <a:gs pos="50000">
+              <a:schemeClr val="phClr">
+                <a:tint val="98000"/>
+                <a:satMod val="130000"/>
+                <a:shade val="90000"/>
+                <a:lumMod val="103000"/>
+              </a:schemeClr>
+            </a:gs>
+            <a:gs pos="100000">
+              <a:schemeClr val="phClr">
+                <a:shade val="63000"/>
+                <a:satMod val="120000"/>
+              </a:schemeClr>
+            </a:gs>
+          </a:gsLst>
+          <a:lin ang="5400000" scaled="0"/>
+        </a:gradFill>
       </a:bgFillStyleLst>
     </a:fmtScheme>
   </a:themeElements>

</xml_diff>